<commit_message>
Mainly revised the CAD_Portfolio_Highlights.pptx and the top-level README.md.
Also touched up the other PowerPoints and README files, but to a much lesser extent.
</commit_message>
<xml_diff>
--- a/Project3_Fusion360_Bobblestat_Biosensor/Project3_Bobblestat_Biosensor_Overview.pptx
+++ b/Project3_Fusion360_Bobblestat_Biosensor/Project3_Bobblestat_Biosensor_Overview.pptx
@@ -131,6 +131,538 @@
 <file path=ppt/changesInfos/changesInfo1.xml><?xml version="1.0" encoding="utf-8"?>
 <pc:chgInfo xmlns:a="http://schemas.openxmlformats.org/drawingml/2006/main" xmlns:r="http://schemas.openxmlformats.org/officeDocument/2006/relationships" xmlns:ac="http://schemas.microsoft.com/office/drawing/2013/main/command" xmlns:pc="http://schemas.microsoft.com/office/powerpoint/2013/main/command">
   <pc:docChgLst>
+    <pc:chgData name="Jason Chen" userId="ad652ca3-8ddd-474a-8ac5-da1049da0a80" providerId="ADAL" clId="{854B7067-BE72-42D6-8712-D3B11DF77CB9}"/>
+    <pc:docChg chg="undo custSel addSld delSld modSld">
+      <pc:chgData name="Jason Chen" userId="ad652ca3-8ddd-474a-8ac5-da1049da0a80" providerId="ADAL" clId="{854B7067-BE72-42D6-8712-D3B11DF77CB9}" dt="2025-06-11T00:44:39.999" v="1796" actId="680"/>
+      <pc:docMkLst>
+        <pc:docMk/>
+      </pc:docMkLst>
+      <pc:sldChg chg="modSp mod">
+        <pc:chgData name="Jason Chen" userId="ad652ca3-8ddd-474a-8ac5-da1049da0a80" providerId="ADAL" clId="{854B7067-BE72-42D6-8712-D3B11DF77CB9}" dt="2025-05-22T02:17:09.964" v="1612" actId="20577"/>
+        <pc:sldMkLst>
+          <pc:docMk/>
+          <pc:sldMk cId="1891355725" sldId="256"/>
+        </pc:sldMkLst>
+        <pc:spChg chg="mod">
+          <ac:chgData name="Jason Chen" userId="ad652ca3-8ddd-474a-8ac5-da1049da0a80" providerId="ADAL" clId="{854B7067-BE72-42D6-8712-D3B11DF77CB9}" dt="2025-05-22T02:17:09.964" v="1612" actId="20577"/>
+          <ac:spMkLst>
+            <pc:docMk/>
+            <pc:sldMk cId="1891355725" sldId="256"/>
+            <ac:spMk id="3" creationId="{7D63CCF5-D557-1820-725A-0D9FBA162437}"/>
+          </ac:spMkLst>
+        </pc:spChg>
+      </pc:sldChg>
+      <pc:sldChg chg="modSp mod">
+        <pc:chgData name="Jason Chen" userId="ad652ca3-8ddd-474a-8ac5-da1049da0a80" providerId="ADAL" clId="{854B7067-BE72-42D6-8712-D3B11DF77CB9}" dt="2025-06-11T00:44:38.921" v="1794" actId="20577"/>
+        <pc:sldMkLst>
+          <pc:docMk/>
+          <pc:sldMk cId="3781449415" sldId="257"/>
+        </pc:sldMkLst>
+        <pc:spChg chg="mod">
+          <ac:chgData name="Jason Chen" userId="ad652ca3-8ddd-474a-8ac5-da1049da0a80" providerId="ADAL" clId="{854B7067-BE72-42D6-8712-D3B11DF77CB9}" dt="2025-06-11T00:44:38.921" v="1794" actId="20577"/>
+          <ac:spMkLst>
+            <pc:docMk/>
+            <pc:sldMk cId="3781449415" sldId="257"/>
+            <ac:spMk id="2" creationId="{F7DE7BE4-7167-569D-09AB-ED1048327899}"/>
+          </ac:spMkLst>
+        </pc:spChg>
+        <pc:spChg chg="mod">
+          <ac:chgData name="Jason Chen" userId="ad652ca3-8ddd-474a-8ac5-da1049da0a80" providerId="ADAL" clId="{854B7067-BE72-42D6-8712-D3B11DF77CB9}" dt="2025-05-21T02:16:26.109" v="1557" actId="20577"/>
+          <ac:spMkLst>
+            <pc:docMk/>
+            <pc:sldMk cId="3781449415" sldId="257"/>
+            <ac:spMk id="8" creationId="{F1FCF42E-9A36-345E-1209-643C4B2FDAE8}"/>
+          </ac:spMkLst>
+        </pc:spChg>
+        <pc:spChg chg="mod">
+          <ac:chgData name="Jason Chen" userId="ad652ca3-8ddd-474a-8ac5-da1049da0a80" providerId="ADAL" clId="{854B7067-BE72-42D6-8712-D3B11DF77CB9}" dt="2025-05-20T21:49:46.032" v="1277" actId="403"/>
+          <ac:spMkLst>
+            <pc:docMk/>
+            <pc:sldMk cId="3781449415" sldId="257"/>
+            <ac:spMk id="9" creationId="{D3578B8C-3008-EB4C-224C-8F48ECBAE8C8}"/>
+          </ac:spMkLst>
+        </pc:spChg>
+        <pc:spChg chg="mod">
+          <ac:chgData name="Jason Chen" userId="ad652ca3-8ddd-474a-8ac5-da1049da0a80" providerId="ADAL" clId="{854B7067-BE72-42D6-8712-D3B11DF77CB9}" dt="2025-05-20T21:49:45.661" v="1276" actId="403"/>
+          <ac:spMkLst>
+            <pc:docMk/>
+            <pc:sldMk cId="3781449415" sldId="257"/>
+            <ac:spMk id="10" creationId="{7C685A67-58FD-97B0-7BC3-66ADF60463A2}"/>
+          </ac:spMkLst>
+        </pc:spChg>
+        <pc:spChg chg="mod">
+          <ac:chgData name="Jason Chen" userId="ad652ca3-8ddd-474a-8ac5-da1049da0a80" providerId="ADAL" clId="{854B7067-BE72-42D6-8712-D3B11DF77CB9}" dt="2025-05-20T21:24:00.047" v="568" actId="20577"/>
+          <ac:spMkLst>
+            <pc:docMk/>
+            <pc:sldMk cId="3781449415" sldId="257"/>
+            <ac:spMk id="15" creationId="{EC6BD5AD-DACF-AF78-F7D4-0D062D2213D0}"/>
+          </ac:spMkLst>
+        </pc:spChg>
+        <pc:spChg chg="mod">
+          <ac:chgData name="Jason Chen" userId="ad652ca3-8ddd-474a-8ac5-da1049da0a80" providerId="ADAL" clId="{854B7067-BE72-42D6-8712-D3B11DF77CB9}" dt="2025-05-20T21:49:46.391" v="1278" actId="403"/>
+          <ac:spMkLst>
+            <pc:docMk/>
+            <pc:sldMk cId="3781449415" sldId="257"/>
+            <ac:spMk id="17" creationId="{E69FA298-1EF3-5FB8-7356-D93FD809C81F}"/>
+          </ac:spMkLst>
+        </pc:spChg>
+        <pc:spChg chg="mod">
+          <ac:chgData name="Jason Chen" userId="ad652ca3-8ddd-474a-8ac5-da1049da0a80" providerId="ADAL" clId="{854B7067-BE72-42D6-8712-D3B11DF77CB9}" dt="2025-05-21T02:15:53.448" v="1553" actId="20577"/>
+          <ac:spMkLst>
+            <pc:docMk/>
+            <pc:sldMk cId="3781449415" sldId="257"/>
+            <ac:spMk id="71" creationId="{194197E8-15D1-3009-346B-72C1D5BC4367}"/>
+          </ac:spMkLst>
+        </pc:spChg>
+        <pc:cxnChg chg="mod">
+          <ac:chgData name="Jason Chen" userId="ad652ca3-8ddd-474a-8ac5-da1049da0a80" providerId="ADAL" clId="{854B7067-BE72-42D6-8712-D3B11DF77CB9}" dt="2025-05-20T21:51:44.650" v="1295" actId="14861"/>
+          <ac:cxnSpMkLst>
+            <pc:docMk/>
+            <pc:sldMk cId="3781449415" sldId="257"/>
+            <ac:cxnSpMk id="19" creationId="{131CE680-4266-C934-92E0-0CE46A1E9062}"/>
+          </ac:cxnSpMkLst>
+        </pc:cxnChg>
+        <pc:cxnChg chg="mod">
+          <ac:chgData name="Jason Chen" userId="ad652ca3-8ddd-474a-8ac5-da1049da0a80" providerId="ADAL" clId="{854B7067-BE72-42D6-8712-D3B11DF77CB9}" dt="2025-05-20T21:51:52.693" v="1296" actId="14861"/>
+          <ac:cxnSpMkLst>
+            <pc:docMk/>
+            <pc:sldMk cId="3781449415" sldId="257"/>
+            <ac:cxnSpMk id="21" creationId="{47F3423B-0F46-09B7-C758-ADB9D893AFD6}"/>
+          </ac:cxnSpMkLst>
+        </pc:cxnChg>
+        <pc:cxnChg chg="mod">
+          <ac:chgData name="Jason Chen" userId="ad652ca3-8ddd-474a-8ac5-da1049da0a80" providerId="ADAL" clId="{854B7067-BE72-42D6-8712-D3B11DF77CB9}" dt="2025-05-20T21:52:11.458" v="1298" actId="14861"/>
+          <ac:cxnSpMkLst>
+            <pc:docMk/>
+            <pc:sldMk cId="3781449415" sldId="257"/>
+            <ac:cxnSpMk id="26" creationId="{AB2B11A4-507F-4715-2ABE-267E7F5DB579}"/>
+          </ac:cxnSpMkLst>
+        </pc:cxnChg>
+        <pc:cxnChg chg="mod">
+          <ac:chgData name="Jason Chen" userId="ad652ca3-8ddd-474a-8ac5-da1049da0a80" providerId="ADAL" clId="{854B7067-BE72-42D6-8712-D3B11DF77CB9}" dt="2025-05-20T21:52:11.458" v="1298" actId="14861"/>
+          <ac:cxnSpMkLst>
+            <pc:docMk/>
+            <pc:sldMk cId="3781449415" sldId="257"/>
+            <ac:cxnSpMk id="28" creationId="{C683C863-5068-9026-6B10-09480A97B05B}"/>
+          </ac:cxnSpMkLst>
+        </pc:cxnChg>
+        <pc:cxnChg chg="mod">
+          <ac:chgData name="Jason Chen" userId="ad652ca3-8ddd-474a-8ac5-da1049da0a80" providerId="ADAL" clId="{854B7067-BE72-42D6-8712-D3B11DF77CB9}" dt="2025-05-20T21:52:11.458" v="1298" actId="14861"/>
+          <ac:cxnSpMkLst>
+            <pc:docMk/>
+            <pc:sldMk cId="3781449415" sldId="257"/>
+            <ac:cxnSpMk id="29" creationId="{48FE67E2-9DB8-532F-54FA-B968B1A4376D}"/>
+          </ac:cxnSpMkLst>
+        </pc:cxnChg>
+        <pc:cxnChg chg="mod">
+          <ac:chgData name="Jason Chen" userId="ad652ca3-8ddd-474a-8ac5-da1049da0a80" providerId="ADAL" clId="{854B7067-BE72-42D6-8712-D3B11DF77CB9}" dt="2025-05-20T21:52:11.458" v="1298" actId="14861"/>
+          <ac:cxnSpMkLst>
+            <pc:docMk/>
+            <pc:sldMk cId="3781449415" sldId="257"/>
+            <ac:cxnSpMk id="30" creationId="{B8058B50-0D1B-4A9A-3741-EF81FCBA997A}"/>
+          </ac:cxnSpMkLst>
+        </pc:cxnChg>
+        <pc:cxnChg chg="mod">
+          <ac:chgData name="Jason Chen" userId="ad652ca3-8ddd-474a-8ac5-da1049da0a80" providerId="ADAL" clId="{854B7067-BE72-42D6-8712-D3B11DF77CB9}" dt="2025-05-20T21:52:11.458" v="1298" actId="14861"/>
+          <ac:cxnSpMkLst>
+            <pc:docMk/>
+            <pc:sldMk cId="3781449415" sldId="257"/>
+            <ac:cxnSpMk id="31" creationId="{7DA05F62-841C-5770-C326-BCB633D695B2}"/>
+          </ac:cxnSpMkLst>
+        </pc:cxnChg>
+        <pc:cxnChg chg="mod">
+          <ac:chgData name="Jason Chen" userId="ad652ca3-8ddd-474a-8ac5-da1049da0a80" providerId="ADAL" clId="{854B7067-BE72-42D6-8712-D3B11DF77CB9}" dt="2025-05-20T21:52:11.458" v="1298" actId="14861"/>
+          <ac:cxnSpMkLst>
+            <pc:docMk/>
+            <pc:sldMk cId="3781449415" sldId="257"/>
+            <ac:cxnSpMk id="32" creationId="{68363A6F-D5A4-AD45-19BB-ADBFAA382F8B}"/>
+          </ac:cxnSpMkLst>
+        </pc:cxnChg>
+        <pc:cxnChg chg="mod">
+          <ac:chgData name="Jason Chen" userId="ad652ca3-8ddd-474a-8ac5-da1049da0a80" providerId="ADAL" clId="{854B7067-BE72-42D6-8712-D3B11DF77CB9}" dt="2025-05-20T21:51:56.792" v="1297" actId="14861"/>
+          <ac:cxnSpMkLst>
+            <pc:docMk/>
+            <pc:sldMk cId="3781449415" sldId="257"/>
+            <ac:cxnSpMk id="33" creationId="{A2487BD6-9FA7-315B-94A3-7297B5BF6883}"/>
+          </ac:cxnSpMkLst>
+        </pc:cxnChg>
+        <pc:cxnChg chg="mod">
+          <ac:chgData name="Jason Chen" userId="ad652ca3-8ddd-474a-8ac5-da1049da0a80" providerId="ADAL" clId="{854B7067-BE72-42D6-8712-D3B11DF77CB9}" dt="2025-05-20T21:52:11.458" v="1298" actId="14861"/>
+          <ac:cxnSpMkLst>
+            <pc:docMk/>
+            <pc:sldMk cId="3781449415" sldId="257"/>
+            <ac:cxnSpMk id="34" creationId="{0C12B29E-8639-76B1-2F41-97DB77740B38}"/>
+          </ac:cxnSpMkLst>
+        </pc:cxnChg>
+        <pc:cxnChg chg="mod">
+          <ac:chgData name="Jason Chen" userId="ad652ca3-8ddd-474a-8ac5-da1049da0a80" providerId="ADAL" clId="{854B7067-BE72-42D6-8712-D3B11DF77CB9}" dt="2025-05-21T02:16:26.109" v="1557" actId="20577"/>
+          <ac:cxnSpMkLst>
+            <pc:docMk/>
+            <pc:sldMk cId="3781449415" sldId="257"/>
+            <ac:cxnSpMk id="45" creationId="{2F4263C1-D5A1-84A6-CCDB-47DE83C610A5}"/>
+          </ac:cxnSpMkLst>
+        </pc:cxnChg>
+        <pc:cxnChg chg="mod">
+          <ac:chgData name="Jason Chen" userId="ad652ca3-8ddd-474a-8ac5-da1049da0a80" providerId="ADAL" clId="{854B7067-BE72-42D6-8712-D3B11DF77CB9}" dt="2025-05-21T02:16:26.109" v="1557" actId="20577"/>
+          <ac:cxnSpMkLst>
+            <pc:docMk/>
+            <pc:sldMk cId="3781449415" sldId="257"/>
+            <ac:cxnSpMk id="48" creationId="{1DCA0292-51AB-B74F-F1E5-81094D940599}"/>
+          </ac:cxnSpMkLst>
+        </pc:cxnChg>
+        <pc:cxnChg chg="mod">
+          <ac:chgData name="Jason Chen" userId="ad652ca3-8ddd-474a-8ac5-da1049da0a80" providerId="ADAL" clId="{854B7067-BE72-42D6-8712-D3B11DF77CB9}" dt="2025-05-21T02:15:53.448" v="1553" actId="20577"/>
+          <ac:cxnSpMkLst>
+            <pc:docMk/>
+            <pc:sldMk cId="3781449415" sldId="257"/>
+            <ac:cxnSpMk id="72" creationId="{B9F9F4FB-9B7A-2D72-1E22-85F96713F681}"/>
+          </ac:cxnSpMkLst>
+        </pc:cxnChg>
+      </pc:sldChg>
+      <pc:sldChg chg="addSp modSp mod">
+        <pc:chgData name="Jason Chen" userId="ad652ca3-8ddd-474a-8ac5-da1049da0a80" providerId="ADAL" clId="{854B7067-BE72-42D6-8712-D3B11DF77CB9}" dt="2025-06-11T00:44:38.426" v="1793" actId="20577"/>
+        <pc:sldMkLst>
+          <pc:docMk/>
+          <pc:sldMk cId="4234757187" sldId="258"/>
+        </pc:sldMkLst>
+        <pc:spChg chg="mod">
+          <ac:chgData name="Jason Chen" userId="ad652ca3-8ddd-474a-8ac5-da1049da0a80" providerId="ADAL" clId="{854B7067-BE72-42D6-8712-D3B11DF77CB9}" dt="2025-06-11T00:44:38.426" v="1793" actId="20577"/>
+          <ac:spMkLst>
+            <pc:docMk/>
+            <pc:sldMk cId="4234757187" sldId="258"/>
+            <ac:spMk id="2" creationId="{25EDC03B-EFEF-9F02-D13A-F50B15E4982F}"/>
+          </ac:spMkLst>
+        </pc:spChg>
+        <pc:spChg chg="mod">
+          <ac:chgData name="Jason Chen" userId="ad652ca3-8ddd-474a-8ac5-da1049da0a80" providerId="ADAL" clId="{854B7067-BE72-42D6-8712-D3B11DF77CB9}" dt="2025-05-22T02:27:57.717" v="1685" actId="14100"/>
+          <ac:spMkLst>
+            <pc:docMk/>
+            <pc:sldMk cId="4234757187" sldId="258"/>
+            <ac:spMk id="8" creationId="{DDC4FE65-0FCD-09C7-8CCD-FE2C14520EC2}"/>
+          </ac:spMkLst>
+        </pc:spChg>
+        <pc:grpChg chg="add mod">
+          <ac:chgData name="Jason Chen" userId="ad652ca3-8ddd-474a-8ac5-da1049da0a80" providerId="ADAL" clId="{854B7067-BE72-42D6-8712-D3B11DF77CB9}" dt="2025-05-20T22:12:57.846" v="1514" actId="1076"/>
+          <ac:grpSpMkLst>
+            <pc:docMk/>
+            <pc:sldMk cId="4234757187" sldId="258"/>
+            <ac:grpSpMk id="3" creationId="{CD0ED6F6-CB18-B790-4B08-C7FA3C8A1ED0}"/>
+          </ac:grpSpMkLst>
+        </pc:grpChg>
+        <pc:picChg chg="mod">
+          <ac:chgData name="Jason Chen" userId="ad652ca3-8ddd-474a-8ac5-da1049da0a80" providerId="ADAL" clId="{854B7067-BE72-42D6-8712-D3B11DF77CB9}" dt="2025-05-20T21:46:13.999" v="992" actId="1076"/>
+          <ac:picMkLst>
+            <pc:docMk/>
+            <pc:sldMk cId="4234757187" sldId="258"/>
+            <ac:picMk id="5" creationId="{04CE8DFD-6FEC-6B06-1736-04B73FCAEAF3}"/>
+          </ac:picMkLst>
+        </pc:picChg>
+        <pc:picChg chg="mod">
+          <ac:chgData name="Jason Chen" userId="ad652ca3-8ddd-474a-8ac5-da1049da0a80" providerId="ADAL" clId="{854B7067-BE72-42D6-8712-D3B11DF77CB9}" dt="2025-05-20T22:12:57.846" v="1514" actId="1076"/>
+          <ac:picMkLst>
+            <pc:docMk/>
+            <pc:sldMk cId="4234757187" sldId="258"/>
+            <ac:picMk id="1026" creationId="{9ED58143-76FB-3958-9836-49420BE822E4}"/>
+          </ac:picMkLst>
+        </pc:picChg>
+        <pc:picChg chg="mod">
+          <ac:chgData name="Jason Chen" userId="ad652ca3-8ddd-474a-8ac5-da1049da0a80" providerId="ADAL" clId="{854B7067-BE72-42D6-8712-D3B11DF77CB9}" dt="2025-05-20T22:12:57.846" v="1514" actId="1076"/>
+          <ac:picMkLst>
+            <pc:docMk/>
+            <pc:sldMk cId="4234757187" sldId="258"/>
+            <ac:picMk id="1028" creationId="{CE1A7E91-6A12-6680-9677-58C88EDF94ED}"/>
+          </ac:picMkLst>
+        </pc:picChg>
+      </pc:sldChg>
+      <pc:sldChg chg="addSp delSp modSp mod">
+        <pc:chgData name="Jason Chen" userId="ad652ca3-8ddd-474a-8ac5-da1049da0a80" providerId="ADAL" clId="{854B7067-BE72-42D6-8712-D3B11DF77CB9}" dt="2025-05-22T02:26:59.294" v="1635" actId="1076"/>
+        <pc:sldMkLst>
+          <pc:docMk/>
+          <pc:sldMk cId="229579759" sldId="259"/>
+        </pc:sldMkLst>
+        <pc:spChg chg="mod">
+          <ac:chgData name="Jason Chen" userId="ad652ca3-8ddd-474a-8ac5-da1049da0a80" providerId="ADAL" clId="{854B7067-BE72-42D6-8712-D3B11DF77CB9}" dt="2025-05-20T21:46:38.590" v="1004" actId="20577"/>
+          <ac:spMkLst>
+            <pc:docMk/>
+            <pc:sldMk cId="229579759" sldId="259"/>
+            <ac:spMk id="2" creationId="{14432A9F-4D79-16E5-2AC1-30420B77BD97}"/>
+          </ac:spMkLst>
+        </pc:spChg>
+        <pc:spChg chg="mod">
+          <ac:chgData name="Jason Chen" userId="ad652ca3-8ddd-474a-8ac5-da1049da0a80" providerId="ADAL" clId="{854B7067-BE72-42D6-8712-D3B11DF77CB9}" dt="2025-05-21T02:21:00.567" v="1573" actId="20577"/>
+          <ac:spMkLst>
+            <pc:docMk/>
+            <pc:sldMk cId="229579759" sldId="259"/>
+            <ac:spMk id="3" creationId="{D0438039-DD94-93F1-84BD-3B1B7F0FD6CE}"/>
+          </ac:spMkLst>
+        </pc:spChg>
+        <pc:picChg chg="add mod">
+          <ac:chgData name="Jason Chen" userId="ad652ca3-8ddd-474a-8ac5-da1049da0a80" providerId="ADAL" clId="{854B7067-BE72-42D6-8712-D3B11DF77CB9}" dt="2025-05-22T02:26:59.294" v="1635" actId="1076"/>
+          <ac:picMkLst>
+            <pc:docMk/>
+            <pc:sldMk cId="229579759" sldId="259"/>
+            <ac:picMk id="4" creationId="{5BA5707D-9059-E173-4BA2-17B15B5B184F}"/>
+          </ac:picMkLst>
+        </pc:picChg>
+        <pc:picChg chg="add mod ord">
+          <ac:chgData name="Jason Chen" userId="ad652ca3-8ddd-474a-8ac5-da1049da0a80" providerId="ADAL" clId="{854B7067-BE72-42D6-8712-D3B11DF77CB9}" dt="2025-05-22T02:26:25.645" v="1629" actId="1076"/>
+          <ac:picMkLst>
+            <pc:docMk/>
+            <pc:sldMk cId="229579759" sldId="259"/>
+            <ac:picMk id="6" creationId="{C4310156-0C15-DBA2-B768-08467AE210C2}"/>
+          </ac:picMkLst>
+        </pc:picChg>
+      </pc:sldChg>
+      <pc:sldChg chg="addSp delSp modSp mod">
+        <pc:chgData name="Jason Chen" userId="ad652ca3-8ddd-474a-8ac5-da1049da0a80" providerId="ADAL" clId="{854B7067-BE72-42D6-8712-D3B11DF77CB9}" dt="2025-05-21T18:34:32.900" v="1588" actId="20577"/>
+        <pc:sldMkLst>
+          <pc:docMk/>
+          <pc:sldMk cId="219224671" sldId="260"/>
+        </pc:sldMkLst>
+        <pc:spChg chg="add del mod">
+          <ac:chgData name="Jason Chen" userId="ad652ca3-8ddd-474a-8ac5-da1049da0a80" providerId="ADAL" clId="{854B7067-BE72-42D6-8712-D3B11DF77CB9}" dt="2025-05-21T18:34:32.900" v="1588" actId="20577"/>
+          <ac:spMkLst>
+            <pc:docMk/>
+            <pc:sldMk cId="219224671" sldId="260"/>
+            <ac:spMk id="3" creationId="{68F95015-D9C7-0BF8-1C8F-08510127B376}"/>
+          </ac:spMkLst>
+        </pc:spChg>
+      </pc:sldChg>
+      <pc:sldChg chg="addSp modSp new mod">
+        <pc:chgData name="Jason Chen" userId="ad652ca3-8ddd-474a-8ac5-da1049da0a80" providerId="ADAL" clId="{854B7067-BE72-42D6-8712-D3B11DF77CB9}" dt="2025-05-21T02:22:11.329" v="1585" actId="20577"/>
+        <pc:sldMkLst>
+          <pc:docMk/>
+          <pc:sldMk cId="3163342603" sldId="261"/>
+        </pc:sldMkLst>
+        <pc:spChg chg="mod">
+          <ac:chgData name="Jason Chen" userId="ad652ca3-8ddd-474a-8ac5-da1049da0a80" providerId="ADAL" clId="{854B7067-BE72-42D6-8712-D3B11DF77CB9}" dt="2025-05-20T21:47:06.260" v="1029" actId="20577"/>
+          <ac:spMkLst>
+            <pc:docMk/>
+            <pc:sldMk cId="3163342603" sldId="261"/>
+            <ac:spMk id="2" creationId="{A4779D7F-824E-C22B-931F-6F423EF2F255}"/>
+          </ac:spMkLst>
+        </pc:spChg>
+        <pc:spChg chg="mod">
+          <ac:chgData name="Jason Chen" userId="ad652ca3-8ddd-474a-8ac5-da1049da0a80" providerId="ADAL" clId="{854B7067-BE72-42D6-8712-D3B11DF77CB9}" dt="2025-05-21T02:22:11.329" v="1585" actId="20577"/>
+          <ac:spMkLst>
+            <pc:docMk/>
+            <pc:sldMk cId="3163342603" sldId="261"/>
+            <ac:spMk id="3" creationId="{6DD79063-8BF1-8B26-1A6A-4F4903094F72}"/>
+          </ac:spMkLst>
+        </pc:spChg>
+        <pc:grpChg chg="add mod ord">
+          <ac:chgData name="Jason Chen" userId="ad652ca3-8ddd-474a-8ac5-da1049da0a80" providerId="ADAL" clId="{854B7067-BE72-42D6-8712-D3B11DF77CB9}" dt="2025-05-20T21:52:44.463" v="1304" actId="14100"/>
+          <ac:grpSpMkLst>
+            <pc:docMk/>
+            <pc:sldMk cId="3163342603" sldId="261"/>
+            <ac:grpSpMk id="8" creationId="{301EECD6-C7B0-0219-D41A-E0E33E2C42E4}"/>
+          </ac:grpSpMkLst>
+        </pc:grpChg>
+        <pc:picChg chg="add mod">
+          <ac:chgData name="Jason Chen" userId="ad652ca3-8ddd-474a-8ac5-da1049da0a80" providerId="ADAL" clId="{854B7067-BE72-42D6-8712-D3B11DF77CB9}" dt="2025-05-20T21:43:45.516" v="809" actId="164"/>
+          <ac:picMkLst>
+            <pc:docMk/>
+            <pc:sldMk cId="3163342603" sldId="261"/>
+            <ac:picMk id="5" creationId="{FC235775-855A-5F09-F329-CD2BB3117F06}"/>
+          </ac:picMkLst>
+        </pc:picChg>
+        <pc:picChg chg="add mod">
+          <ac:chgData name="Jason Chen" userId="ad652ca3-8ddd-474a-8ac5-da1049da0a80" providerId="ADAL" clId="{854B7067-BE72-42D6-8712-D3B11DF77CB9}" dt="2025-05-20T21:43:45.516" v="809" actId="164"/>
+          <ac:picMkLst>
+            <pc:docMk/>
+            <pc:sldMk cId="3163342603" sldId="261"/>
+            <ac:picMk id="7" creationId="{ED99E906-808B-554E-90A5-4AE8CFA522A5}"/>
+          </ac:picMkLst>
+        </pc:picChg>
+      </pc:sldChg>
+      <pc:sldChg chg="addSp delSp modSp new mod">
+        <pc:chgData name="Jason Chen" userId="ad652ca3-8ddd-474a-8ac5-da1049da0a80" providerId="ADAL" clId="{854B7067-BE72-42D6-8712-D3B11DF77CB9}" dt="2025-05-21T02:22:24.724" v="1586" actId="12"/>
+        <pc:sldMkLst>
+          <pc:docMk/>
+          <pc:sldMk cId="2239138709" sldId="262"/>
+        </pc:sldMkLst>
+        <pc:spChg chg="mod">
+          <ac:chgData name="Jason Chen" userId="ad652ca3-8ddd-474a-8ac5-da1049da0a80" providerId="ADAL" clId="{854B7067-BE72-42D6-8712-D3B11DF77CB9}" dt="2025-05-20T21:47:27.780" v="1064" actId="20577"/>
+          <ac:spMkLst>
+            <pc:docMk/>
+            <pc:sldMk cId="2239138709" sldId="262"/>
+            <ac:spMk id="2" creationId="{805F59C8-7E86-4749-92AE-33804E680EF4}"/>
+          </ac:spMkLst>
+        </pc:spChg>
+        <pc:spChg chg="add mod">
+          <ac:chgData name="Jason Chen" userId="ad652ca3-8ddd-474a-8ac5-da1049da0a80" providerId="ADAL" clId="{854B7067-BE72-42D6-8712-D3B11DF77CB9}" dt="2025-05-21T02:22:24.724" v="1586" actId="12"/>
+          <ac:spMkLst>
+            <pc:docMk/>
+            <pc:sldMk cId="2239138709" sldId="262"/>
+            <ac:spMk id="12" creationId="{9FF47832-5B8B-3170-BFEA-BCE6EEF76FDA}"/>
+          </ac:spMkLst>
+        </pc:spChg>
+        <pc:spChg chg="add mod">
+          <ac:chgData name="Jason Chen" userId="ad652ca3-8ddd-474a-8ac5-da1049da0a80" providerId="ADAL" clId="{854B7067-BE72-42D6-8712-D3B11DF77CB9}" dt="2025-05-21T02:15:04.583" v="1544" actId="20577"/>
+          <ac:spMkLst>
+            <pc:docMk/>
+            <pc:sldMk cId="2239138709" sldId="262"/>
+            <ac:spMk id="13" creationId="{0A8A6CAC-A8AA-5D97-54B6-A24200CA0A50}"/>
+          </ac:spMkLst>
+        </pc:spChg>
+        <pc:spChg chg="add mod">
+          <ac:chgData name="Jason Chen" userId="ad652ca3-8ddd-474a-8ac5-da1049da0a80" providerId="ADAL" clId="{854B7067-BE72-42D6-8712-D3B11DF77CB9}" dt="2025-05-21T02:15:00.948" v="1540" actId="20577"/>
+          <ac:spMkLst>
+            <pc:docMk/>
+            <pc:sldMk cId="2239138709" sldId="262"/>
+            <ac:spMk id="27" creationId="{E99A169D-C202-BEA2-77E4-5602DD07D6D6}"/>
+          </ac:spMkLst>
+        </pc:spChg>
+        <pc:picChg chg="add mod">
+          <ac:chgData name="Jason Chen" userId="ad652ca3-8ddd-474a-8ac5-da1049da0a80" providerId="ADAL" clId="{854B7067-BE72-42D6-8712-D3B11DF77CB9}" dt="2025-05-21T00:54:30.970" v="1517" actId="1076"/>
+          <ac:picMkLst>
+            <pc:docMk/>
+            <pc:sldMk cId="2239138709" sldId="262"/>
+            <ac:picMk id="5" creationId="{66A71AA1-5944-C714-5B0D-65D61ED0661D}"/>
+          </ac:picMkLst>
+        </pc:picChg>
+        <pc:picChg chg="add mod">
+          <ac:chgData name="Jason Chen" userId="ad652ca3-8ddd-474a-8ac5-da1049da0a80" providerId="ADAL" clId="{854B7067-BE72-42D6-8712-D3B11DF77CB9}" dt="2025-05-21T00:55:11.078" v="1522" actId="1076"/>
+          <ac:picMkLst>
+            <pc:docMk/>
+            <pc:sldMk cId="2239138709" sldId="262"/>
+            <ac:picMk id="7" creationId="{9F5D5678-5085-128A-B0A5-2E86D798EBEB}"/>
+          </ac:picMkLst>
+        </pc:picChg>
+        <pc:picChg chg="add mod modCrop">
+          <ac:chgData name="Jason Chen" userId="ad652ca3-8ddd-474a-8ac5-da1049da0a80" providerId="ADAL" clId="{854B7067-BE72-42D6-8712-D3B11DF77CB9}" dt="2025-05-20T22:01:00.626" v="1437" actId="1076"/>
+          <ac:picMkLst>
+            <pc:docMk/>
+            <pc:sldMk cId="2239138709" sldId="262"/>
+            <ac:picMk id="11" creationId="{80C2769C-0927-B8AF-58B0-D4CE3336D780}"/>
+          </ac:picMkLst>
+        </pc:picChg>
+        <pc:cxnChg chg="add mod">
+          <ac:chgData name="Jason Chen" userId="ad652ca3-8ddd-474a-8ac5-da1049da0a80" providerId="ADAL" clId="{854B7067-BE72-42D6-8712-D3B11DF77CB9}" dt="2025-05-21T00:56:21.818" v="1530" actId="14100"/>
+          <ac:cxnSpMkLst>
+            <pc:docMk/>
+            <pc:sldMk cId="2239138709" sldId="262"/>
+            <ac:cxnSpMk id="14" creationId="{0130A8FA-F6D2-60FB-F733-40177CCF3506}"/>
+          </ac:cxnSpMkLst>
+        </pc:cxnChg>
+        <pc:cxnChg chg="add mod">
+          <ac:chgData name="Jason Chen" userId="ad652ca3-8ddd-474a-8ac5-da1049da0a80" providerId="ADAL" clId="{854B7067-BE72-42D6-8712-D3B11DF77CB9}" dt="2025-05-21T00:56:29.950" v="1532" actId="14100"/>
+          <ac:cxnSpMkLst>
+            <pc:docMk/>
+            <pc:sldMk cId="2239138709" sldId="262"/>
+            <ac:cxnSpMk id="15" creationId="{01F4F60B-794D-B6B0-0CED-A048D487062A}"/>
+          </ac:cxnSpMkLst>
+        </pc:cxnChg>
+        <pc:cxnChg chg="add mod">
+          <ac:chgData name="Jason Chen" userId="ad652ca3-8ddd-474a-8ac5-da1049da0a80" providerId="ADAL" clId="{854B7067-BE72-42D6-8712-D3B11DF77CB9}" dt="2025-05-21T02:15:00.948" v="1540" actId="20577"/>
+          <ac:cxnSpMkLst>
+            <pc:docMk/>
+            <pc:sldMk cId="2239138709" sldId="262"/>
+            <ac:cxnSpMk id="28" creationId="{0C7EF8E9-A27D-997E-0169-A7F8B7014F5F}"/>
+          </ac:cxnSpMkLst>
+        </pc:cxnChg>
+        <pc:cxnChg chg="add mod">
+          <ac:chgData name="Jason Chen" userId="ad652ca3-8ddd-474a-8ac5-da1049da0a80" providerId="ADAL" clId="{854B7067-BE72-42D6-8712-D3B11DF77CB9}" dt="2025-05-21T02:15:00.948" v="1540" actId="20577"/>
+          <ac:cxnSpMkLst>
+            <pc:docMk/>
+            <pc:sldMk cId="2239138709" sldId="262"/>
+            <ac:cxnSpMk id="29" creationId="{CCD01BFF-EB29-0850-1B87-0DD66C1C30BA}"/>
+          </ac:cxnSpMkLst>
+        </pc:cxnChg>
+        <pc:cxnChg chg="add mod">
+          <ac:chgData name="Jason Chen" userId="ad652ca3-8ddd-474a-8ac5-da1049da0a80" providerId="ADAL" clId="{854B7067-BE72-42D6-8712-D3B11DF77CB9}" dt="2025-05-21T00:56:24.746" v="1531" actId="14100"/>
+          <ac:cxnSpMkLst>
+            <pc:docMk/>
+            <pc:sldMk cId="2239138709" sldId="262"/>
+            <ac:cxnSpMk id="32" creationId="{E72B1A9F-1BC2-96C2-8567-C3F1EC3944A9}"/>
+          </ac:cxnSpMkLst>
+        </pc:cxnChg>
+        <pc:cxnChg chg="add mod">
+          <ac:chgData name="Jason Chen" userId="ad652ca3-8ddd-474a-8ac5-da1049da0a80" providerId="ADAL" clId="{854B7067-BE72-42D6-8712-D3B11DF77CB9}" dt="2025-05-21T00:56:21.818" v="1530" actId="14100"/>
+          <ac:cxnSpMkLst>
+            <pc:docMk/>
+            <pc:sldMk cId="2239138709" sldId="262"/>
+            <ac:cxnSpMk id="35" creationId="{2EE8FC86-9A3C-57C4-0231-2D3C777C20E8}"/>
+          </ac:cxnSpMkLst>
+        </pc:cxnChg>
+      </pc:sldChg>
+      <pc:sldChg chg="add del">
+        <pc:chgData name="Jason Chen" userId="ad652ca3-8ddd-474a-8ac5-da1049da0a80" providerId="ADAL" clId="{854B7067-BE72-42D6-8712-D3B11DF77CB9}" dt="2025-05-22T02:23:02.958" v="1614"/>
+        <pc:sldMkLst>
+          <pc:docMk/>
+          <pc:sldMk cId="355277942" sldId="263"/>
+        </pc:sldMkLst>
+      </pc:sldChg>
+      <pc:sldChg chg="addSp delSp modSp new mod modAnim">
+        <pc:chgData name="Jason Chen" userId="ad652ca3-8ddd-474a-8ac5-da1049da0a80" providerId="ADAL" clId="{854B7067-BE72-42D6-8712-D3B11DF77CB9}" dt="2025-06-11T00:44:37.954" v="1792" actId="1076"/>
+        <pc:sldMkLst>
+          <pc:docMk/>
+          <pc:sldMk cId="1277809651" sldId="263"/>
+        </pc:sldMkLst>
+        <pc:spChg chg="mod">
+          <ac:chgData name="Jason Chen" userId="ad652ca3-8ddd-474a-8ac5-da1049da0a80" providerId="ADAL" clId="{854B7067-BE72-42D6-8712-D3B11DF77CB9}" dt="2025-05-31T08:30:23.897" v="1714" actId="20577"/>
+          <ac:spMkLst>
+            <pc:docMk/>
+            <pc:sldMk cId="1277809651" sldId="263"/>
+            <ac:spMk id="2" creationId="{E85F87C3-3430-1F7F-CDAB-0CE90DDF3799}"/>
+          </ac:spMkLst>
+        </pc:spChg>
+        <pc:picChg chg="add mod">
+          <ac:chgData name="Jason Chen" userId="ad652ca3-8ddd-474a-8ac5-da1049da0a80" providerId="ADAL" clId="{854B7067-BE72-42D6-8712-D3B11DF77CB9}" dt="2025-06-11T00:44:37.954" v="1792" actId="1076"/>
+          <ac:picMkLst>
+            <pc:docMk/>
+            <pc:sldMk cId="1277809651" sldId="263"/>
+            <ac:picMk id="4" creationId="{ADFE6397-955B-27E1-33F1-602140FE6091}"/>
+          </ac:picMkLst>
+        </pc:picChg>
+      </pc:sldChg>
+      <pc:sldChg chg="addSp delSp modSp new mod modAnim">
+        <pc:chgData name="Jason Chen" userId="ad652ca3-8ddd-474a-8ac5-da1049da0a80" providerId="ADAL" clId="{854B7067-BE72-42D6-8712-D3B11DF77CB9}" dt="2025-06-03T20:59:13.084" v="1776" actId="1035"/>
+        <pc:sldMkLst>
+          <pc:docMk/>
+          <pc:sldMk cId="14455331" sldId="264"/>
+        </pc:sldMkLst>
+        <pc:spChg chg="mod">
+          <ac:chgData name="Jason Chen" userId="ad652ca3-8ddd-474a-8ac5-da1049da0a80" providerId="ADAL" clId="{854B7067-BE72-42D6-8712-D3B11DF77CB9}" dt="2025-06-03T20:52:49.230" v="1763" actId="20577"/>
+          <ac:spMkLst>
+            <pc:docMk/>
+            <pc:sldMk cId="14455331" sldId="264"/>
+            <ac:spMk id="2" creationId="{122F5CD3-F842-6A52-922B-9CBE618D932B}"/>
+          </ac:spMkLst>
+        </pc:spChg>
+        <pc:picChg chg="add mod">
+          <ac:chgData name="Jason Chen" userId="ad652ca3-8ddd-474a-8ac5-da1049da0a80" providerId="ADAL" clId="{854B7067-BE72-42D6-8712-D3B11DF77CB9}" dt="2025-06-03T20:59:13.084" v="1776" actId="1035"/>
+          <ac:picMkLst>
+            <pc:docMk/>
+            <pc:sldMk cId="14455331" sldId="264"/>
+            <ac:picMk id="4" creationId="{1774AAFC-22C2-3704-3BC1-F00AE87B6814}"/>
+          </ac:picMkLst>
+        </pc:picChg>
+      </pc:sldChg>
+      <pc:sldChg chg="add del">
+        <pc:chgData name="Jason Chen" userId="ad652ca3-8ddd-474a-8ac5-da1049da0a80" providerId="ADAL" clId="{854B7067-BE72-42D6-8712-D3B11DF77CB9}" dt="2025-05-31T08:30:29.567" v="1716"/>
+        <pc:sldMkLst>
+          <pc:docMk/>
+          <pc:sldMk cId="2108586889" sldId="264"/>
+        </pc:sldMkLst>
+      </pc:sldChg>
+      <pc:sldChg chg="new del">
+        <pc:chgData name="Jason Chen" userId="ad652ca3-8ddd-474a-8ac5-da1049da0a80" providerId="ADAL" clId="{854B7067-BE72-42D6-8712-D3B11DF77CB9}" dt="2025-06-11T00:44:39.999" v="1796" actId="680"/>
+        <pc:sldMkLst>
+          <pc:docMk/>
+          <pc:sldMk cId="2346573525" sldId="265"/>
+        </pc:sldMkLst>
+      </pc:sldChg>
+      <pc:sldChg chg="new del">
+        <pc:chgData name="Jason Chen" userId="ad652ca3-8ddd-474a-8ac5-da1049da0a80" providerId="ADAL" clId="{854B7067-BE72-42D6-8712-D3B11DF77CB9}" dt="2025-06-11T00:44:39.395" v="1795" actId="680"/>
+        <pc:sldMkLst>
+          <pc:docMk/>
+          <pc:sldMk cId="772032724" sldId="266"/>
+        </pc:sldMkLst>
+      </pc:sldChg>
+    </pc:docChg>
+  </pc:docChgLst>
+  <pc:docChgLst>
     <pc:chgData name="Jason Chen" userId="ad652ca3-8ddd-474a-8ac5-da1049da0a80" providerId="ADAL" clId="{9184DCA0-1D34-4BF0-8B27-530AE16BB611}"/>
     <pc:docChg chg="undo custSel addSld delSld modSld">
       <pc:chgData name="Jason Chen" userId="ad652ca3-8ddd-474a-8ac5-da1049da0a80" providerId="ADAL" clId="{9184DCA0-1D34-4BF0-8B27-530AE16BB611}" dt="2025-05-20T02:42:55.021" v="1024" actId="20577"/>
@@ -450,532 +982,6 @@
             <ac:spMk id="2" creationId="{DA89359F-998F-0BC2-F872-A05E20E0D5C0}"/>
           </ac:spMkLst>
         </pc:spChg>
-      </pc:sldChg>
-    </pc:docChg>
-  </pc:docChgLst>
-  <pc:docChgLst>
-    <pc:chgData name="Jason Chen" userId="ad652ca3-8ddd-474a-8ac5-da1049da0a80" providerId="ADAL" clId="{854B7067-BE72-42D6-8712-D3B11DF77CB9}"/>
-    <pc:docChg chg="undo custSel addSld delSld modSld">
-      <pc:chgData name="Jason Chen" userId="ad652ca3-8ddd-474a-8ac5-da1049da0a80" providerId="ADAL" clId="{854B7067-BE72-42D6-8712-D3B11DF77CB9}" dt="2025-06-03T20:59:13.084" v="1776" actId="1035"/>
-      <pc:docMkLst>
-        <pc:docMk/>
-      </pc:docMkLst>
-      <pc:sldChg chg="modSp mod">
-        <pc:chgData name="Jason Chen" userId="ad652ca3-8ddd-474a-8ac5-da1049da0a80" providerId="ADAL" clId="{854B7067-BE72-42D6-8712-D3B11DF77CB9}" dt="2025-05-22T02:17:09.964" v="1612" actId="20577"/>
-        <pc:sldMkLst>
-          <pc:docMk/>
-          <pc:sldMk cId="1891355725" sldId="256"/>
-        </pc:sldMkLst>
-        <pc:spChg chg="mod">
-          <ac:chgData name="Jason Chen" userId="ad652ca3-8ddd-474a-8ac5-da1049da0a80" providerId="ADAL" clId="{854B7067-BE72-42D6-8712-D3B11DF77CB9}" dt="2025-05-22T02:17:09.964" v="1612" actId="20577"/>
-          <ac:spMkLst>
-            <pc:docMk/>
-            <pc:sldMk cId="1891355725" sldId="256"/>
-            <ac:spMk id="3" creationId="{7D63CCF5-D557-1820-725A-0D9FBA162437}"/>
-          </ac:spMkLst>
-        </pc:spChg>
-      </pc:sldChg>
-      <pc:sldChg chg="modSp mod">
-        <pc:chgData name="Jason Chen" userId="ad652ca3-8ddd-474a-8ac5-da1049da0a80" providerId="ADAL" clId="{854B7067-BE72-42D6-8712-D3B11DF77CB9}" dt="2025-05-21T02:16:26.109" v="1557" actId="20577"/>
-        <pc:sldMkLst>
-          <pc:docMk/>
-          <pc:sldMk cId="3781449415" sldId="257"/>
-        </pc:sldMkLst>
-        <pc:spChg chg="mod">
-          <ac:chgData name="Jason Chen" userId="ad652ca3-8ddd-474a-8ac5-da1049da0a80" providerId="ADAL" clId="{854B7067-BE72-42D6-8712-D3B11DF77CB9}" dt="2025-05-20T21:46:32.960" v="1003" actId="20577"/>
-          <ac:spMkLst>
-            <pc:docMk/>
-            <pc:sldMk cId="3781449415" sldId="257"/>
-            <ac:spMk id="2" creationId="{F7DE7BE4-7167-569D-09AB-ED1048327899}"/>
-          </ac:spMkLst>
-        </pc:spChg>
-        <pc:spChg chg="mod">
-          <ac:chgData name="Jason Chen" userId="ad652ca3-8ddd-474a-8ac5-da1049da0a80" providerId="ADAL" clId="{854B7067-BE72-42D6-8712-D3B11DF77CB9}" dt="2025-05-21T02:16:26.109" v="1557" actId="20577"/>
-          <ac:spMkLst>
-            <pc:docMk/>
-            <pc:sldMk cId="3781449415" sldId="257"/>
-            <ac:spMk id="8" creationId="{F1FCF42E-9A36-345E-1209-643C4B2FDAE8}"/>
-          </ac:spMkLst>
-        </pc:spChg>
-        <pc:spChg chg="mod">
-          <ac:chgData name="Jason Chen" userId="ad652ca3-8ddd-474a-8ac5-da1049da0a80" providerId="ADAL" clId="{854B7067-BE72-42D6-8712-D3B11DF77CB9}" dt="2025-05-20T21:49:46.032" v="1277" actId="403"/>
-          <ac:spMkLst>
-            <pc:docMk/>
-            <pc:sldMk cId="3781449415" sldId="257"/>
-            <ac:spMk id="9" creationId="{D3578B8C-3008-EB4C-224C-8F48ECBAE8C8}"/>
-          </ac:spMkLst>
-        </pc:spChg>
-        <pc:spChg chg="mod">
-          <ac:chgData name="Jason Chen" userId="ad652ca3-8ddd-474a-8ac5-da1049da0a80" providerId="ADAL" clId="{854B7067-BE72-42D6-8712-D3B11DF77CB9}" dt="2025-05-20T21:49:45.661" v="1276" actId="403"/>
-          <ac:spMkLst>
-            <pc:docMk/>
-            <pc:sldMk cId="3781449415" sldId="257"/>
-            <ac:spMk id="10" creationId="{7C685A67-58FD-97B0-7BC3-66ADF60463A2}"/>
-          </ac:spMkLst>
-        </pc:spChg>
-        <pc:spChg chg="mod">
-          <ac:chgData name="Jason Chen" userId="ad652ca3-8ddd-474a-8ac5-da1049da0a80" providerId="ADAL" clId="{854B7067-BE72-42D6-8712-D3B11DF77CB9}" dt="2025-05-20T21:24:00.047" v="568" actId="20577"/>
-          <ac:spMkLst>
-            <pc:docMk/>
-            <pc:sldMk cId="3781449415" sldId="257"/>
-            <ac:spMk id="15" creationId="{EC6BD5AD-DACF-AF78-F7D4-0D062D2213D0}"/>
-          </ac:spMkLst>
-        </pc:spChg>
-        <pc:spChg chg="mod">
-          <ac:chgData name="Jason Chen" userId="ad652ca3-8ddd-474a-8ac5-da1049da0a80" providerId="ADAL" clId="{854B7067-BE72-42D6-8712-D3B11DF77CB9}" dt="2025-05-20T21:49:46.391" v="1278" actId="403"/>
-          <ac:spMkLst>
-            <pc:docMk/>
-            <pc:sldMk cId="3781449415" sldId="257"/>
-            <ac:spMk id="17" creationId="{E69FA298-1EF3-5FB8-7356-D93FD809C81F}"/>
-          </ac:spMkLst>
-        </pc:spChg>
-        <pc:spChg chg="mod">
-          <ac:chgData name="Jason Chen" userId="ad652ca3-8ddd-474a-8ac5-da1049da0a80" providerId="ADAL" clId="{854B7067-BE72-42D6-8712-D3B11DF77CB9}" dt="2025-05-21T02:15:53.448" v="1553" actId="20577"/>
-          <ac:spMkLst>
-            <pc:docMk/>
-            <pc:sldMk cId="3781449415" sldId="257"/>
-            <ac:spMk id="71" creationId="{194197E8-15D1-3009-346B-72C1D5BC4367}"/>
-          </ac:spMkLst>
-        </pc:spChg>
-        <pc:cxnChg chg="mod">
-          <ac:chgData name="Jason Chen" userId="ad652ca3-8ddd-474a-8ac5-da1049da0a80" providerId="ADAL" clId="{854B7067-BE72-42D6-8712-D3B11DF77CB9}" dt="2025-05-20T21:51:44.650" v="1295" actId="14861"/>
-          <ac:cxnSpMkLst>
-            <pc:docMk/>
-            <pc:sldMk cId="3781449415" sldId="257"/>
-            <ac:cxnSpMk id="19" creationId="{131CE680-4266-C934-92E0-0CE46A1E9062}"/>
-          </ac:cxnSpMkLst>
-        </pc:cxnChg>
-        <pc:cxnChg chg="mod">
-          <ac:chgData name="Jason Chen" userId="ad652ca3-8ddd-474a-8ac5-da1049da0a80" providerId="ADAL" clId="{854B7067-BE72-42D6-8712-D3B11DF77CB9}" dt="2025-05-20T21:51:52.693" v="1296" actId="14861"/>
-          <ac:cxnSpMkLst>
-            <pc:docMk/>
-            <pc:sldMk cId="3781449415" sldId="257"/>
-            <ac:cxnSpMk id="21" creationId="{47F3423B-0F46-09B7-C758-ADB9D893AFD6}"/>
-          </ac:cxnSpMkLst>
-        </pc:cxnChg>
-        <pc:cxnChg chg="mod">
-          <ac:chgData name="Jason Chen" userId="ad652ca3-8ddd-474a-8ac5-da1049da0a80" providerId="ADAL" clId="{854B7067-BE72-42D6-8712-D3B11DF77CB9}" dt="2025-05-20T21:52:11.458" v="1298" actId="14861"/>
-          <ac:cxnSpMkLst>
-            <pc:docMk/>
-            <pc:sldMk cId="3781449415" sldId="257"/>
-            <ac:cxnSpMk id="26" creationId="{AB2B11A4-507F-4715-2ABE-267E7F5DB579}"/>
-          </ac:cxnSpMkLst>
-        </pc:cxnChg>
-        <pc:cxnChg chg="mod">
-          <ac:chgData name="Jason Chen" userId="ad652ca3-8ddd-474a-8ac5-da1049da0a80" providerId="ADAL" clId="{854B7067-BE72-42D6-8712-D3B11DF77CB9}" dt="2025-05-20T21:52:11.458" v="1298" actId="14861"/>
-          <ac:cxnSpMkLst>
-            <pc:docMk/>
-            <pc:sldMk cId="3781449415" sldId="257"/>
-            <ac:cxnSpMk id="28" creationId="{C683C863-5068-9026-6B10-09480A97B05B}"/>
-          </ac:cxnSpMkLst>
-        </pc:cxnChg>
-        <pc:cxnChg chg="mod">
-          <ac:chgData name="Jason Chen" userId="ad652ca3-8ddd-474a-8ac5-da1049da0a80" providerId="ADAL" clId="{854B7067-BE72-42D6-8712-D3B11DF77CB9}" dt="2025-05-20T21:52:11.458" v="1298" actId="14861"/>
-          <ac:cxnSpMkLst>
-            <pc:docMk/>
-            <pc:sldMk cId="3781449415" sldId="257"/>
-            <ac:cxnSpMk id="29" creationId="{48FE67E2-9DB8-532F-54FA-B968B1A4376D}"/>
-          </ac:cxnSpMkLst>
-        </pc:cxnChg>
-        <pc:cxnChg chg="mod">
-          <ac:chgData name="Jason Chen" userId="ad652ca3-8ddd-474a-8ac5-da1049da0a80" providerId="ADAL" clId="{854B7067-BE72-42D6-8712-D3B11DF77CB9}" dt="2025-05-20T21:52:11.458" v="1298" actId="14861"/>
-          <ac:cxnSpMkLst>
-            <pc:docMk/>
-            <pc:sldMk cId="3781449415" sldId="257"/>
-            <ac:cxnSpMk id="30" creationId="{B8058B50-0D1B-4A9A-3741-EF81FCBA997A}"/>
-          </ac:cxnSpMkLst>
-        </pc:cxnChg>
-        <pc:cxnChg chg="mod">
-          <ac:chgData name="Jason Chen" userId="ad652ca3-8ddd-474a-8ac5-da1049da0a80" providerId="ADAL" clId="{854B7067-BE72-42D6-8712-D3B11DF77CB9}" dt="2025-05-20T21:52:11.458" v="1298" actId="14861"/>
-          <ac:cxnSpMkLst>
-            <pc:docMk/>
-            <pc:sldMk cId="3781449415" sldId="257"/>
-            <ac:cxnSpMk id="31" creationId="{7DA05F62-841C-5770-C326-BCB633D695B2}"/>
-          </ac:cxnSpMkLst>
-        </pc:cxnChg>
-        <pc:cxnChg chg="mod">
-          <ac:chgData name="Jason Chen" userId="ad652ca3-8ddd-474a-8ac5-da1049da0a80" providerId="ADAL" clId="{854B7067-BE72-42D6-8712-D3B11DF77CB9}" dt="2025-05-20T21:52:11.458" v="1298" actId="14861"/>
-          <ac:cxnSpMkLst>
-            <pc:docMk/>
-            <pc:sldMk cId="3781449415" sldId="257"/>
-            <ac:cxnSpMk id="32" creationId="{68363A6F-D5A4-AD45-19BB-ADBFAA382F8B}"/>
-          </ac:cxnSpMkLst>
-        </pc:cxnChg>
-        <pc:cxnChg chg="mod">
-          <ac:chgData name="Jason Chen" userId="ad652ca3-8ddd-474a-8ac5-da1049da0a80" providerId="ADAL" clId="{854B7067-BE72-42D6-8712-D3B11DF77CB9}" dt="2025-05-20T21:51:56.792" v="1297" actId="14861"/>
-          <ac:cxnSpMkLst>
-            <pc:docMk/>
-            <pc:sldMk cId="3781449415" sldId="257"/>
-            <ac:cxnSpMk id="33" creationId="{A2487BD6-9FA7-315B-94A3-7297B5BF6883}"/>
-          </ac:cxnSpMkLst>
-        </pc:cxnChg>
-        <pc:cxnChg chg="mod">
-          <ac:chgData name="Jason Chen" userId="ad652ca3-8ddd-474a-8ac5-da1049da0a80" providerId="ADAL" clId="{854B7067-BE72-42D6-8712-D3B11DF77CB9}" dt="2025-05-20T21:52:11.458" v="1298" actId="14861"/>
-          <ac:cxnSpMkLst>
-            <pc:docMk/>
-            <pc:sldMk cId="3781449415" sldId="257"/>
-            <ac:cxnSpMk id="34" creationId="{0C12B29E-8639-76B1-2F41-97DB77740B38}"/>
-          </ac:cxnSpMkLst>
-        </pc:cxnChg>
-        <pc:cxnChg chg="mod">
-          <ac:chgData name="Jason Chen" userId="ad652ca3-8ddd-474a-8ac5-da1049da0a80" providerId="ADAL" clId="{854B7067-BE72-42D6-8712-D3B11DF77CB9}" dt="2025-05-21T02:16:26.109" v="1557" actId="20577"/>
-          <ac:cxnSpMkLst>
-            <pc:docMk/>
-            <pc:sldMk cId="3781449415" sldId="257"/>
-            <ac:cxnSpMk id="45" creationId="{2F4263C1-D5A1-84A6-CCDB-47DE83C610A5}"/>
-          </ac:cxnSpMkLst>
-        </pc:cxnChg>
-        <pc:cxnChg chg="mod">
-          <ac:chgData name="Jason Chen" userId="ad652ca3-8ddd-474a-8ac5-da1049da0a80" providerId="ADAL" clId="{854B7067-BE72-42D6-8712-D3B11DF77CB9}" dt="2025-05-21T02:16:26.109" v="1557" actId="20577"/>
-          <ac:cxnSpMkLst>
-            <pc:docMk/>
-            <pc:sldMk cId="3781449415" sldId="257"/>
-            <ac:cxnSpMk id="48" creationId="{1DCA0292-51AB-B74F-F1E5-81094D940599}"/>
-          </ac:cxnSpMkLst>
-        </pc:cxnChg>
-        <pc:cxnChg chg="mod">
-          <ac:chgData name="Jason Chen" userId="ad652ca3-8ddd-474a-8ac5-da1049da0a80" providerId="ADAL" clId="{854B7067-BE72-42D6-8712-D3B11DF77CB9}" dt="2025-05-21T02:15:53.448" v="1553" actId="20577"/>
-          <ac:cxnSpMkLst>
-            <pc:docMk/>
-            <pc:sldMk cId="3781449415" sldId="257"/>
-            <ac:cxnSpMk id="72" creationId="{B9F9F4FB-9B7A-2D72-1E22-85F96713F681}"/>
-          </ac:cxnSpMkLst>
-        </pc:cxnChg>
-      </pc:sldChg>
-      <pc:sldChg chg="addSp modSp mod">
-        <pc:chgData name="Jason Chen" userId="ad652ca3-8ddd-474a-8ac5-da1049da0a80" providerId="ADAL" clId="{854B7067-BE72-42D6-8712-D3B11DF77CB9}" dt="2025-05-22T02:27:57.717" v="1685" actId="14100"/>
-        <pc:sldMkLst>
-          <pc:docMk/>
-          <pc:sldMk cId="4234757187" sldId="258"/>
-        </pc:sldMkLst>
-        <pc:spChg chg="mod">
-          <ac:chgData name="Jason Chen" userId="ad652ca3-8ddd-474a-8ac5-da1049da0a80" providerId="ADAL" clId="{854B7067-BE72-42D6-8712-D3B11DF77CB9}" dt="2025-05-20T22:12:36.144" v="1513" actId="20577"/>
-          <ac:spMkLst>
-            <pc:docMk/>
-            <pc:sldMk cId="4234757187" sldId="258"/>
-            <ac:spMk id="2" creationId="{25EDC03B-EFEF-9F02-D13A-F50B15E4982F}"/>
-          </ac:spMkLst>
-        </pc:spChg>
-        <pc:spChg chg="mod">
-          <ac:chgData name="Jason Chen" userId="ad652ca3-8ddd-474a-8ac5-da1049da0a80" providerId="ADAL" clId="{854B7067-BE72-42D6-8712-D3B11DF77CB9}" dt="2025-05-22T02:27:57.717" v="1685" actId="14100"/>
-          <ac:spMkLst>
-            <pc:docMk/>
-            <pc:sldMk cId="4234757187" sldId="258"/>
-            <ac:spMk id="8" creationId="{DDC4FE65-0FCD-09C7-8CCD-FE2C14520EC2}"/>
-          </ac:spMkLst>
-        </pc:spChg>
-        <pc:grpChg chg="add mod">
-          <ac:chgData name="Jason Chen" userId="ad652ca3-8ddd-474a-8ac5-da1049da0a80" providerId="ADAL" clId="{854B7067-BE72-42D6-8712-D3B11DF77CB9}" dt="2025-05-20T22:12:57.846" v="1514" actId="1076"/>
-          <ac:grpSpMkLst>
-            <pc:docMk/>
-            <pc:sldMk cId="4234757187" sldId="258"/>
-            <ac:grpSpMk id="3" creationId="{CD0ED6F6-CB18-B790-4B08-C7FA3C8A1ED0}"/>
-          </ac:grpSpMkLst>
-        </pc:grpChg>
-        <pc:picChg chg="mod">
-          <ac:chgData name="Jason Chen" userId="ad652ca3-8ddd-474a-8ac5-da1049da0a80" providerId="ADAL" clId="{854B7067-BE72-42D6-8712-D3B11DF77CB9}" dt="2025-05-20T21:46:13.999" v="992" actId="1076"/>
-          <ac:picMkLst>
-            <pc:docMk/>
-            <pc:sldMk cId="4234757187" sldId="258"/>
-            <ac:picMk id="5" creationId="{04CE8DFD-6FEC-6B06-1736-04B73FCAEAF3}"/>
-          </ac:picMkLst>
-        </pc:picChg>
-        <pc:picChg chg="mod">
-          <ac:chgData name="Jason Chen" userId="ad652ca3-8ddd-474a-8ac5-da1049da0a80" providerId="ADAL" clId="{854B7067-BE72-42D6-8712-D3B11DF77CB9}" dt="2025-05-20T22:12:57.846" v="1514" actId="1076"/>
-          <ac:picMkLst>
-            <pc:docMk/>
-            <pc:sldMk cId="4234757187" sldId="258"/>
-            <ac:picMk id="1026" creationId="{9ED58143-76FB-3958-9836-49420BE822E4}"/>
-          </ac:picMkLst>
-        </pc:picChg>
-        <pc:picChg chg="mod">
-          <ac:chgData name="Jason Chen" userId="ad652ca3-8ddd-474a-8ac5-da1049da0a80" providerId="ADAL" clId="{854B7067-BE72-42D6-8712-D3B11DF77CB9}" dt="2025-05-20T22:12:57.846" v="1514" actId="1076"/>
-          <ac:picMkLst>
-            <pc:docMk/>
-            <pc:sldMk cId="4234757187" sldId="258"/>
-            <ac:picMk id="1028" creationId="{CE1A7E91-6A12-6680-9677-58C88EDF94ED}"/>
-          </ac:picMkLst>
-        </pc:picChg>
-      </pc:sldChg>
-      <pc:sldChg chg="addSp delSp modSp mod">
-        <pc:chgData name="Jason Chen" userId="ad652ca3-8ddd-474a-8ac5-da1049da0a80" providerId="ADAL" clId="{854B7067-BE72-42D6-8712-D3B11DF77CB9}" dt="2025-05-22T02:26:59.294" v="1635" actId="1076"/>
-        <pc:sldMkLst>
-          <pc:docMk/>
-          <pc:sldMk cId="229579759" sldId="259"/>
-        </pc:sldMkLst>
-        <pc:spChg chg="mod">
-          <ac:chgData name="Jason Chen" userId="ad652ca3-8ddd-474a-8ac5-da1049da0a80" providerId="ADAL" clId="{854B7067-BE72-42D6-8712-D3B11DF77CB9}" dt="2025-05-20T21:46:38.590" v="1004" actId="20577"/>
-          <ac:spMkLst>
-            <pc:docMk/>
-            <pc:sldMk cId="229579759" sldId="259"/>
-            <ac:spMk id="2" creationId="{14432A9F-4D79-16E5-2AC1-30420B77BD97}"/>
-          </ac:spMkLst>
-        </pc:spChg>
-        <pc:spChg chg="mod">
-          <ac:chgData name="Jason Chen" userId="ad652ca3-8ddd-474a-8ac5-da1049da0a80" providerId="ADAL" clId="{854B7067-BE72-42D6-8712-D3B11DF77CB9}" dt="2025-05-21T02:21:00.567" v="1573" actId="20577"/>
-          <ac:spMkLst>
-            <pc:docMk/>
-            <pc:sldMk cId="229579759" sldId="259"/>
-            <ac:spMk id="3" creationId="{D0438039-DD94-93F1-84BD-3B1B7F0FD6CE}"/>
-          </ac:spMkLst>
-        </pc:spChg>
-        <pc:picChg chg="add mod">
-          <ac:chgData name="Jason Chen" userId="ad652ca3-8ddd-474a-8ac5-da1049da0a80" providerId="ADAL" clId="{854B7067-BE72-42D6-8712-D3B11DF77CB9}" dt="2025-05-22T02:26:59.294" v="1635" actId="1076"/>
-          <ac:picMkLst>
-            <pc:docMk/>
-            <pc:sldMk cId="229579759" sldId="259"/>
-            <ac:picMk id="4" creationId="{5BA5707D-9059-E173-4BA2-17B15B5B184F}"/>
-          </ac:picMkLst>
-        </pc:picChg>
-        <pc:picChg chg="add mod ord">
-          <ac:chgData name="Jason Chen" userId="ad652ca3-8ddd-474a-8ac5-da1049da0a80" providerId="ADAL" clId="{854B7067-BE72-42D6-8712-D3B11DF77CB9}" dt="2025-05-22T02:26:25.645" v="1629" actId="1076"/>
-          <ac:picMkLst>
-            <pc:docMk/>
-            <pc:sldMk cId="229579759" sldId="259"/>
-            <ac:picMk id="6" creationId="{C4310156-0C15-DBA2-B768-08467AE210C2}"/>
-          </ac:picMkLst>
-        </pc:picChg>
-      </pc:sldChg>
-      <pc:sldChg chg="addSp delSp modSp mod">
-        <pc:chgData name="Jason Chen" userId="ad652ca3-8ddd-474a-8ac5-da1049da0a80" providerId="ADAL" clId="{854B7067-BE72-42D6-8712-D3B11DF77CB9}" dt="2025-05-21T18:34:32.900" v="1588" actId="20577"/>
-        <pc:sldMkLst>
-          <pc:docMk/>
-          <pc:sldMk cId="219224671" sldId="260"/>
-        </pc:sldMkLst>
-        <pc:spChg chg="add del mod">
-          <ac:chgData name="Jason Chen" userId="ad652ca3-8ddd-474a-8ac5-da1049da0a80" providerId="ADAL" clId="{854B7067-BE72-42D6-8712-D3B11DF77CB9}" dt="2025-05-21T18:34:32.900" v="1588" actId="20577"/>
-          <ac:spMkLst>
-            <pc:docMk/>
-            <pc:sldMk cId="219224671" sldId="260"/>
-            <ac:spMk id="3" creationId="{68F95015-D9C7-0BF8-1C8F-08510127B376}"/>
-          </ac:spMkLst>
-        </pc:spChg>
-      </pc:sldChg>
-      <pc:sldChg chg="addSp modSp new mod">
-        <pc:chgData name="Jason Chen" userId="ad652ca3-8ddd-474a-8ac5-da1049da0a80" providerId="ADAL" clId="{854B7067-BE72-42D6-8712-D3B11DF77CB9}" dt="2025-05-21T02:22:11.329" v="1585" actId="20577"/>
-        <pc:sldMkLst>
-          <pc:docMk/>
-          <pc:sldMk cId="3163342603" sldId="261"/>
-        </pc:sldMkLst>
-        <pc:spChg chg="mod">
-          <ac:chgData name="Jason Chen" userId="ad652ca3-8ddd-474a-8ac5-da1049da0a80" providerId="ADAL" clId="{854B7067-BE72-42D6-8712-D3B11DF77CB9}" dt="2025-05-20T21:47:06.260" v="1029" actId="20577"/>
-          <ac:spMkLst>
-            <pc:docMk/>
-            <pc:sldMk cId="3163342603" sldId="261"/>
-            <ac:spMk id="2" creationId="{A4779D7F-824E-C22B-931F-6F423EF2F255}"/>
-          </ac:spMkLst>
-        </pc:spChg>
-        <pc:spChg chg="mod">
-          <ac:chgData name="Jason Chen" userId="ad652ca3-8ddd-474a-8ac5-da1049da0a80" providerId="ADAL" clId="{854B7067-BE72-42D6-8712-D3B11DF77CB9}" dt="2025-05-21T02:22:11.329" v="1585" actId="20577"/>
-          <ac:spMkLst>
-            <pc:docMk/>
-            <pc:sldMk cId="3163342603" sldId="261"/>
-            <ac:spMk id="3" creationId="{6DD79063-8BF1-8B26-1A6A-4F4903094F72}"/>
-          </ac:spMkLst>
-        </pc:spChg>
-        <pc:grpChg chg="add mod ord">
-          <ac:chgData name="Jason Chen" userId="ad652ca3-8ddd-474a-8ac5-da1049da0a80" providerId="ADAL" clId="{854B7067-BE72-42D6-8712-D3B11DF77CB9}" dt="2025-05-20T21:52:44.463" v="1304" actId="14100"/>
-          <ac:grpSpMkLst>
-            <pc:docMk/>
-            <pc:sldMk cId="3163342603" sldId="261"/>
-            <ac:grpSpMk id="8" creationId="{301EECD6-C7B0-0219-D41A-E0E33E2C42E4}"/>
-          </ac:grpSpMkLst>
-        </pc:grpChg>
-        <pc:picChg chg="add mod">
-          <ac:chgData name="Jason Chen" userId="ad652ca3-8ddd-474a-8ac5-da1049da0a80" providerId="ADAL" clId="{854B7067-BE72-42D6-8712-D3B11DF77CB9}" dt="2025-05-20T21:43:45.516" v="809" actId="164"/>
-          <ac:picMkLst>
-            <pc:docMk/>
-            <pc:sldMk cId="3163342603" sldId="261"/>
-            <ac:picMk id="5" creationId="{FC235775-855A-5F09-F329-CD2BB3117F06}"/>
-          </ac:picMkLst>
-        </pc:picChg>
-        <pc:picChg chg="add mod">
-          <ac:chgData name="Jason Chen" userId="ad652ca3-8ddd-474a-8ac5-da1049da0a80" providerId="ADAL" clId="{854B7067-BE72-42D6-8712-D3B11DF77CB9}" dt="2025-05-20T21:43:45.516" v="809" actId="164"/>
-          <ac:picMkLst>
-            <pc:docMk/>
-            <pc:sldMk cId="3163342603" sldId="261"/>
-            <ac:picMk id="7" creationId="{ED99E906-808B-554E-90A5-4AE8CFA522A5}"/>
-          </ac:picMkLst>
-        </pc:picChg>
-      </pc:sldChg>
-      <pc:sldChg chg="addSp delSp modSp new mod">
-        <pc:chgData name="Jason Chen" userId="ad652ca3-8ddd-474a-8ac5-da1049da0a80" providerId="ADAL" clId="{854B7067-BE72-42D6-8712-D3B11DF77CB9}" dt="2025-05-21T02:22:24.724" v="1586" actId="12"/>
-        <pc:sldMkLst>
-          <pc:docMk/>
-          <pc:sldMk cId="2239138709" sldId="262"/>
-        </pc:sldMkLst>
-        <pc:spChg chg="mod">
-          <ac:chgData name="Jason Chen" userId="ad652ca3-8ddd-474a-8ac5-da1049da0a80" providerId="ADAL" clId="{854B7067-BE72-42D6-8712-D3B11DF77CB9}" dt="2025-05-20T21:47:27.780" v="1064" actId="20577"/>
-          <ac:spMkLst>
-            <pc:docMk/>
-            <pc:sldMk cId="2239138709" sldId="262"/>
-            <ac:spMk id="2" creationId="{805F59C8-7E86-4749-92AE-33804E680EF4}"/>
-          </ac:spMkLst>
-        </pc:spChg>
-        <pc:spChg chg="add mod">
-          <ac:chgData name="Jason Chen" userId="ad652ca3-8ddd-474a-8ac5-da1049da0a80" providerId="ADAL" clId="{854B7067-BE72-42D6-8712-D3B11DF77CB9}" dt="2025-05-21T02:22:24.724" v="1586" actId="12"/>
-          <ac:spMkLst>
-            <pc:docMk/>
-            <pc:sldMk cId="2239138709" sldId="262"/>
-            <ac:spMk id="12" creationId="{9FF47832-5B8B-3170-BFEA-BCE6EEF76FDA}"/>
-          </ac:spMkLst>
-        </pc:spChg>
-        <pc:spChg chg="add mod">
-          <ac:chgData name="Jason Chen" userId="ad652ca3-8ddd-474a-8ac5-da1049da0a80" providerId="ADAL" clId="{854B7067-BE72-42D6-8712-D3B11DF77CB9}" dt="2025-05-21T02:15:04.583" v="1544" actId="20577"/>
-          <ac:spMkLst>
-            <pc:docMk/>
-            <pc:sldMk cId="2239138709" sldId="262"/>
-            <ac:spMk id="13" creationId="{0A8A6CAC-A8AA-5D97-54B6-A24200CA0A50}"/>
-          </ac:spMkLst>
-        </pc:spChg>
-        <pc:spChg chg="add mod">
-          <ac:chgData name="Jason Chen" userId="ad652ca3-8ddd-474a-8ac5-da1049da0a80" providerId="ADAL" clId="{854B7067-BE72-42D6-8712-D3B11DF77CB9}" dt="2025-05-21T02:15:00.948" v="1540" actId="20577"/>
-          <ac:spMkLst>
-            <pc:docMk/>
-            <pc:sldMk cId="2239138709" sldId="262"/>
-            <ac:spMk id="27" creationId="{E99A169D-C202-BEA2-77E4-5602DD07D6D6}"/>
-          </ac:spMkLst>
-        </pc:spChg>
-        <pc:picChg chg="add mod">
-          <ac:chgData name="Jason Chen" userId="ad652ca3-8ddd-474a-8ac5-da1049da0a80" providerId="ADAL" clId="{854B7067-BE72-42D6-8712-D3B11DF77CB9}" dt="2025-05-21T00:54:30.970" v="1517" actId="1076"/>
-          <ac:picMkLst>
-            <pc:docMk/>
-            <pc:sldMk cId="2239138709" sldId="262"/>
-            <ac:picMk id="5" creationId="{66A71AA1-5944-C714-5B0D-65D61ED0661D}"/>
-          </ac:picMkLst>
-        </pc:picChg>
-        <pc:picChg chg="add mod">
-          <ac:chgData name="Jason Chen" userId="ad652ca3-8ddd-474a-8ac5-da1049da0a80" providerId="ADAL" clId="{854B7067-BE72-42D6-8712-D3B11DF77CB9}" dt="2025-05-21T00:55:11.078" v="1522" actId="1076"/>
-          <ac:picMkLst>
-            <pc:docMk/>
-            <pc:sldMk cId="2239138709" sldId="262"/>
-            <ac:picMk id="7" creationId="{9F5D5678-5085-128A-B0A5-2E86D798EBEB}"/>
-          </ac:picMkLst>
-        </pc:picChg>
-        <pc:picChg chg="add mod modCrop">
-          <ac:chgData name="Jason Chen" userId="ad652ca3-8ddd-474a-8ac5-da1049da0a80" providerId="ADAL" clId="{854B7067-BE72-42D6-8712-D3B11DF77CB9}" dt="2025-05-20T22:01:00.626" v="1437" actId="1076"/>
-          <ac:picMkLst>
-            <pc:docMk/>
-            <pc:sldMk cId="2239138709" sldId="262"/>
-            <ac:picMk id="11" creationId="{80C2769C-0927-B8AF-58B0-D4CE3336D780}"/>
-          </ac:picMkLst>
-        </pc:picChg>
-        <pc:cxnChg chg="add mod">
-          <ac:chgData name="Jason Chen" userId="ad652ca3-8ddd-474a-8ac5-da1049da0a80" providerId="ADAL" clId="{854B7067-BE72-42D6-8712-D3B11DF77CB9}" dt="2025-05-21T00:56:21.818" v="1530" actId="14100"/>
-          <ac:cxnSpMkLst>
-            <pc:docMk/>
-            <pc:sldMk cId="2239138709" sldId="262"/>
-            <ac:cxnSpMk id="14" creationId="{0130A8FA-F6D2-60FB-F733-40177CCF3506}"/>
-          </ac:cxnSpMkLst>
-        </pc:cxnChg>
-        <pc:cxnChg chg="add mod">
-          <ac:chgData name="Jason Chen" userId="ad652ca3-8ddd-474a-8ac5-da1049da0a80" providerId="ADAL" clId="{854B7067-BE72-42D6-8712-D3B11DF77CB9}" dt="2025-05-21T00:56:29.950" v="1532" actId="14100"/>
-          <ac:cxnSpMkLst>
-            <pc:docMk/>
-            <pc:sldMk cId="2239138709" sldId="262"/>
-            <ac:cxnSpMk id="15" creationId="{01F4F60B-794D-B6B0-0CED-A048D487062A}"/>
-          </ac:cxnSpMkLst>
-        </pc:cxnChg>
-        <pc:cxnChg chg="add mod">
-          <ac:chgData name="Jason Chen" userId="ad652ca3-8ddd-474a-8ac5-da1049da0a80" providerId="ADAL" clId="{854B7067-BE72-42D6-8712-D3B11DF77CB9}" dt="2025-05-21T02:15:00.948" v="1540" actId="20577"/>
-          <ac:cxnSpMkLst>
-            <pc:docMk/>
-            <pc:sldMk cId="2239138709" sldId="262"/>
-            <ac:cxnSpMk id="28" creationId="{0C7EF8E9-A27D-997E-0169-A7F8B7014F5F}"/>
-          </ac:cxnSpMkLst>
-        </pc:cxnChg>
-        <pc:cxnChg chg="add mod">
-          <ac:chgData name="Jason Chen" userId="ad652ca3-8ddd-474a-8ac5-da1049da0a80" providerId="ADAL" clId="{854B7067-BE72-42D6-8712-D3B11DF77CB9}" dt="2025-05-21T02:15:00.948" v="1540" actId="20577"/>
-          <ac:cxnSpMkLst>
-            <pc:docMk/>
-            <pc:sldMk cId="2239138709" sldId="262"/>
-            <ac:cxnSpMk id="29" creationId="{CCD01BFF-EB29-0850-1B87-0DD66C1C30BA}"/>
-          </ac:cxnSpMkLst>
-        </pc:cxnChg>
-        <pc:cxnChg chg="add mod">
-          <ac:chgData name="Jason Chen" userId="ad652ca3-8ddd-474a-8ac5-da1049da0a80" providerId="ADAL" clId="{854B7067-BE72-42D6-8712-D3B11DF77CB9}" dt="2025-05-21T00:56:24.746" v="1531" actId="14100"/>
-          <ac:cxnSpMkLst>
-            <pc:docMk/>
-            <pc:sldMk cId="2239138709" sldId="262"/>
-            <ac:cxnSpMk id="32" creationId="{E72B1A9F-1BC2-96C2-8567-C3F1EC3944A9}"/>
-          </ac:cxnSpMkLst>
-        </pc:cxnChg>
-        <pc:cxnChg chg="add mod">
-          <ac:chgData name="Jason Chen" userId="ad652ca3-8ddd-474a-8ac5-da1049da0a80" providerId="ADAL" clId="{854B7067-BE72-42D6-8712-D3B11DF77CB9}" dt="2025-05-21T00:56:21.818" v="1530" actId="14100"/>
-          <ac:cxnSpMkLst>
-            <pc:docMk/>
-            <pc:sldMk cId="2239138709" sldId="262"/>
-            <ac:cxnSpMk id="35" creationId="{2EE8FC86-9A3C-57C4-0231-2D3C777C20E8}"/>
-          </ac:cxnSpMkLst>
-        </pc:cxnChg>
-      </pc:sldChg>
-      <pc:sldChg chg="add del">
-        <pc:chgData name="Jason Chen" userId="ad652ca3-8ddd-474a-8ac5-da1049da0a80" providerId="ADAL" clId="{854B7067-BE72-42D6-8712-D3B11DF77CB9}" dt="2025-05-22T02:23:02.958" v="1614"/>
-        <pc:sldMkLst>
-          <pc:docMk/>
-          <pc:sldMk cId="355277942" sldId="263"/>
-        </pc:sldMkLst>
-      </pc:sldChg>
-      <pc:sldChg chg="addSp delSp modSp new mod modAnim">
-        <pc:chgData name="Jason Chen" userId="ad652ca3-8ddd-474a-8ac5-da1049da0a80" providerId="ADAL" clId="{854B7067-BE72-42D6-8712-D3B11DF77CB9}" dt="2025-05-31T20:36:16.606" v="1729" actId="1035"/>
-        <pc:sldMkLst>
-          <pc:docMk/>
-          <pc:sldMk cId="1277809651" sldId="263"/>
-        </pc:sldMkLst>
-        <pc:spChg chg="mod">
-          <ac:chgData name="Jason Chen" userId="ad652ca3-8ddd-474a-8ac5-da1049da0a80" providerId="ADAL" clId="{854B7067-BE72-42D6-8712-D3B11DF77CB9}" dt="2025-05-31T08:30:23.897" v="1714" actId="20577"/>
-          <ac:spMkLst>
-            <pc:docMk/>
-            <pc:sldMk cId="1277809651" sldId="263"/>
-            <ac:spMk id="2" creationId="{E85F87C3-3430-1F7F-CDAB-0CE90DDF3799}"/>
-          </ac:spMkLst>
-        </pc:spChg>
-        <pc:picChg chg="add mod">
-          <ac:chgData name="Jason Chen" userId="ad652ca3-8ddd-474a-8ac5-da1049da0a80" providerId="ADAL" clId="{854B7067-BE72-42D6-8712-D3B11DF77CB9}" dt="2025-05-31T20:36:16.606" v="1729" actId="1035"/>
-          <ac:picMkLst>
-            <pc:docMk/>
-            <pc:sldMk cId="1277809651" sldId="263"/>
-            <ac:picMk id="4" creationId="{ADFE6397-955B-27E1-33F1-602140FE6091}"/>
-          </ac:picMkLst>
-        </pc:picChg>
-      </pc:sldChg>
-      <pc:sldChg chg="addSp delSp modSp new mod modAnim">
-        <pc:chgData name="Jason Chen" userId="ad652ca3-8ddd-474a-8ac5-da1049da0a80" providerId="ADAL" clId="{854B7067-BE72-42D6-8712-D3B11DF77CB9}" dt="2025-06-03T20:59:13.084" v="1776" actId="1035"/>
-        <pc:sldMkLst>
-          <pc:docMk/>
-          <pc:sldMk cId="14455331" sldId="264"/>
-        </pc:sldMkLst>
-        <pc:spChg chg="mod">
-          <ac:chgData name="Jason Chen" userId="ad652ca3-8ddd-474a-8ac5-da1049da0a80" providerId="ADAL" clId="{854B7067-BE72-42D6-8712-D3B11DF77CB9}" dt="2025-06-03T20:52:49.230" v="1763" actId="20577"/>
-          <ac:spMkLst>
-            <pc:docMk/>
-            <pc:sldMk cId="14455331" sldId="264"/>
-            <ac:spMk id="2" creationId="{122F5CD3-F842-6A52-922B-9CBE618D932B}"/>
-          </ac:spMkLst>
-        </pc:spChg>
-        <pc:spChg chg="del">
-          <ac:chgData name="Jason Chen" userId="ad652ca3-8ddd-474a-8ac5-da1049da0a80" providerId="ADAL" clId="{854B7067-BE72-42D6-8712-D3B11DF77CB9}" dt="2025-06-03T20:58:20.128" v="1764"/>
-          <ac:spMkLst>
-            <pc:docMk/>
-            <pc:sldMk cId="14455331" sldId="264"/>
-            <ac:spMk id="3" creationId="{10D02CD5-1BDD-FAC6-D226-940D9FA62189}"/>
-          </ac:spMkLst>
-        </pc:spChg>
-        <pc:picChg chg="add mod">
-          <ac:chgData name="Jason Chen" userId="ad652ca3-8ddd-474a-8ac5-da1049da0a80" providerId="ADAL" clId="{854B7067-BE72-42D6-8712-D3B11DF77CB9}" dt="2025-06-03T20:59:13.084" v="1776" actId="1035"/>
-          <ac:picMkLst>
-            <pc:docMk/>
-            <pc:sldMk cId="14455331" sldId="264"/>
-            <ac:picMk id="4" creationId="{1774AAFC-22C2-3704-3BC1-F00AE87B6814}"/>
-          </ac:picMkLst>
-        </pc:picChg>
-      </pc:sldChg>
-      <pc:sldChg chg="add del">
-        <pc:chgData name="Jason Chen" userId="ad652ca3-8ddd-474a-8ac5-da1049da0a80" providerId="ADAL" clId="{854B7067-BE72-42D6-8712-D3B11DF77CB9}" dt="2025-05-31T08:30:29.567" v="1716"/>
-        <pc:sldMkLst>
-          <pc:docMk/>
-          <pc:sldMk cId="2108586889" sldId="264"/>
-        </pc:sldMkLst>
       </pc:sldChg>
     </pc:docChg>
   </pc:docChgLst>
@@ -1129,7 +1135,7 @@
           <a:p>
             <a:fld id="{04652FFF-11A2-42F1-A73A-7CFCAB0DAA85}" type="datetimeFigureOut">
               <a:rPr lang="en-US" smtClean="0"/>
-              <a:t>6/3/2025</a:t>
+              <a:t>6/11/2025</a:t>
             </a:fld>
             <a:endParaRPr lang="en-US"/>
           </a:p>
@@ -1327,7 +1333,7 @@
           <a:p>
             <a:fld id="{04652FFF-11A2-42F1-A73A-7CFCAB0DAA85}" type="datetimeFigureOut">
               <a:rPr lang="en-US" smtClean="0"/>
-              <a:t>6/3/2025</a:t>
+              <a:t>6/11/2025</a:t>
             </a:fld>
             <a:endParaRPr lang="en-US"/>
           </a:p>
@@ -1535,7 +1541,7 @@
           <a:p>
             <a:fld id="{04652FFF-11A2-42F1-A73A-7CFCAB0DAA85}" type="datetimeFigureOut">
               <a:rPr lang="en-US" smtClean="0"/>
-              <a:t>6/3/2025</a:t>
+              <a:t>6/11/2025</a:t>
             </a:fld>
             <a:endParaRPr lang="en-US"/>
           </a:p>
@@ -1733,7 +1739,7 @@
           <a:p>
             <a:fld id="{04652FFF-11A2-42F1-A73A-7CFCAB0DAA85}" type="datetimeFigureOut">
               <a:rPr lang="en-US" smtClean="0"/>
-              <a:t>6/3/2025</a:t>
+              <a:t>6/11/2025</a:t>
             </a:fld>
             <a:endParaRPr lang="en-US"/>
           </a:p>
@@ -2008,7 +2014,7 @@
           <a:p>
             <a:fld id="{04652FFF-11A2-42F1-A73A-7CFCAB0DAA85}" type="datetimeFigureOut">
               <a:rPr lang="en-US" smtClean="0"/>
-              <a:t>6/3/2025</a:t>
+              <a:t>6/11/2025</a:t>
             </a:fld>
             <a:endParaRPr lang="en-US"/>
           </a:p>
@@ -2273,7 +2279,7 @@
           <a:p>
             <a:fld id="{04652FFF-11A2-42F1-A73A-7CFCAB0DAA85}" type="datetimeFigureOut">
               <a:rPr lang="en-US" smtClean="0"/>
-              <a:t>6/3/2025</a:t>
+              <a:t>6/11/2025</a:t>
             </a:fld>
             <a:endParaRPr lang="en-US"/>
           </a:p>
@@ -2685,7 +2691,7 @@
           <a:p>
             <a:fld id="{04652FFF-11A2-42F1-A73A-7CFCAB0DAA85}" type="datetimeFigureOut">
               <a:rPr lang="en-US" smtClean="0"/>
-              <a:t>6/3/2025</a:t>
+              <a:t>6/11/2025</a:t>
             </a:fld>
             <a:endParaRPr lang="en-US"/>
           </a:p>
@@ -2826,7 +2832,7 @@
           <a:p>
             <a:fld id="{04652FFF-11A2-42F1-A73A-7CFCAB0DAA85}" type="datetimeFigureOut">
               <a:rPr lang="en-US" smtClean="0"/>
-              <a:t>6/3/2025</a:t>
+              <a:t>6/11/2025</a:t>
             </a:fld>
             <a:endParaRPr lang="en-US"/>
           </a:p>
@@ -2939,7 +2945,7 @@
           <a:p>
             <a:fld id="{04652FFF-11A2-42F1-A73A-7CFCAB0DAA85}" type="datetimeFigureOut">
               <a:rPr lang="en-US" smtClean="0"/>
-              <a:t>6/3/2025</a:t>
+              <a:t>6/11/2025</a:t>
             </a:fld>
             <a:endParaRPr lang="en-US"/>
           </a:p>
@@ -3250,7 +3256,7 @@
           <a:p>
             <a:fld id="{04652FFF-11A2-42F1-A73A-7CFCAB0DAA85}" type="datetimeFigureOut">
               <a:rPr lang="en-US" smtClean="0"/>
-              <a:t>6/3/2025</a:t>
+              <a:t>6/11/2025</a:t>
             </a:fld>
             <a:endParaRPr lang="en-US"/>
           </a:p>
@@ -3538,7 +3544,7 @@
           <a:p>
             <a:fld id="{04652FFF-11A2-42F1-A73A-7CFCAB0DAA85}" type="datetimeFigureOut">
               <a:rPr lang="en-US" smtClean="0"/>
-              <a:t>6/3/2025</a:t>
+              <a:t>6/11/2025</a:t>
             </a:fld>
             <a:endParaRPr lang="en-US"/>
           </a:p>
@@ -3779,7 +3785,7 @@
           <a:p>
             <a:fld id="{04652FFF-11A2-42F1-A73A-7CFCAB0DAA85}" type="datetimeFigureOut">
               <a:rPr lang="en-US" smtClean="0"/>
-              <a:t>6/3/2025</a:t>
+              <a:t>6/11/2025</a:t>
             </a:fld>
             <a:endParaRPr lang="en-US"/>
           </a:p>
@@ -4605,45 +4611,6 @@
           </p:spPr>
         </p:pic>
       </p:grpSp>
-      <p:sp>
-        <p:nvSpPr>
-          <p:cNvPr id="8" name="TextBox 7">
-            <a:extLst>
-              <a:ext uri="{FF2B5EF4-FFF2-40B4-BE49-F238E27FC236}">
-                <a16:creationId xmlns:a16="http://schemas.microsoft.com/office/drawing/2014/main" id="{DDC4FE65-0FCD-09C7-8CCD-FE2C14520EC2}"/>
-              </a:ext>
-            </a:extLst>
-          </p:cNvPr>
-          <p:cNvSpPr txBox="1"/>
-          <p:nvPr/>
-        </p:nvSpPr>
-        <p:spPr>
-          <a:xfrm>
-            <a:off x="713824" y="6193104"/>
-            <a:ext cx="6222685" cy="646331"/>
-          </a:xfrm>
-          <a:prstGeom prst="rect">
-            <a:avLst/>
-          </a:prstGeom>
-          <a:noFill/>
-        </p:spPr>
-        <p:txBody>
-          <a:bodyPr wrap="square" rtlCol="0">
-            <a:spAutoFit/>
-          </a:bodyPr>
-          <a:lstStyle/>
-          <a:p>
-            <a:r>
-              <a:rPr lang="en-US" b="1" dirty="0"/>
-              <a:t>NOTE</a:t>
-            </a:r>
-            <a:r>
-              <a:rPr lang="en-US" dirty="0"/>
-              <a:t>: the CAD model is an updated version of the prototype. Material selection is not final. </a:t>
-            </a:r>
-          </a:p>
-        </p:txBody>
-      </p:sp>
     </p:spTree>
     <p:extLst>
       <p:ext uri="{BB962C8B-B14F-4D97-AF65-F5344CB8AC3E}">

</xml_diff>